<commit_message>
feat: FEAT-20260601-001 — vivid preset 고도화 (callout bar + chart palette)
- vivid/tokens.json: callout-bar/#6957E8, callout-bar-text/#FFFFFF 추가, chart-1/2 순서 조정 (main→dark→light)
- ContentSlide/FlowSlide schema에 callout?: string 추가 (base 제외 — 적용 가능 타입 명시)
- layout.ts: renderCalloutBar() — callout-bar 토큰 없으면 no-op (teal/modern 영향 없음)
- content.ts/flow.ts: renderCalloutBar를 early return 앞에 배치 — body/diagram 없어도 callout 보장
- compiler.ts: callout 조건 충족 시 footer 억제, RenderFn 타입 불변 유지
- renderer.test.ts: callout bar 단위 테스트 5개 (flow early return 경로, y=6.85 직접 검증)
- snapshot.test.ts: compiler footer 억제 integration test 2개 (토큰 유무별 footer 동작 검증)
- vivid 문서 4종 현행화 (ppt-design, ppt-components, ppt-layouts, ppt-chart-rules)
- strategy-vivid-dark blueprint/pptx 재생성 (page 3 callout 예시 포함)

Co-Authored-By: Claude Sonnet 4.6 <noreply@anthropic.com>
</commit_message>
<xml_diff>
--- a/examples/results/strategy-vivid-dark.pptx
+++ b/examples/results/strategy-vivid-dark.pptx
@@ -2742,14 +2742,39 @@
       </p:sp>
       <p:sp>
         <p:nvSpPr>
-          <p:cNvPr id="7" name="Text 5"/>
-          <p:cNvSpPr/>
-          <p:nvPr/>
-        </p:nvSpPr>
-        <p:spPr>
-          <a:xfrm>
-            <a:off x="9902952" y="6537960"/>
-            <a:ext cx="2286000" cy="274320"/>
+          <p:cNvPr id="7" name="Shape 5"/>
+          <p:cNvSpPr/>
+          <p:nvPr/>
+        </p:nvSpPr>
+        <p:spPr>
+          <a:xfrm>
+            <a:off x="0" y="6263640"/>
+            <a:ext cx="12188952" cy="310896"/>
+          </a:xfrm>
+          <a:prstGeom prst="rect">
+            <a:avLst/>
+          </a:prstGeom>
+          <a:solidFill>
+            <a:srgbClr val="6957E8"/>
+          </a:solidFill>
+          <a:ln w="12700">
+            <a:solidFill>
+              <a:srgbClr val="6957E8"/>
+            </a:solidFill>
+            <a:prstDash val="solid"/>
+          </a:ln>
+        </p:spPr>
+      </p:sp>
+      <p:sp>
+        <p:nvSpPr>
+          <p:cNvPr id="8" name="Text 6"/>
+          <p:cNvSpPr/>
+          <p:nvPr/>
+        </p:nvSpPr>
+        <p:spPr>
+          <a:xfrm>
+            <a:off x="612648" y="6263640"/>
+            <a:ext cx="10972800" cy="310896"/>
           </a:xfrm>
           <a:prstGeom prst="rect">
             <a:avLst/>
@@ -2761,60 +2786,21 @@
           <a:bodyPr wrap="square" rtlCol="0" anchor="ctr"/>
           <a:lstStyle/>
           <a:p>
-            <a:pPr algn="r" indent="0" marL="0">
-              <a:buNone/>
-            </a:pPr>
-            <a:r>
-              <a:rPr lang="en-US" sz="1000" dirty="0">
-                <a:solidFill>
-                  <a:srgbClr val="7A809A"/>
-                </a:solidFill>
-                <a:latin typeface="Pretendard" pitchFamily="34" charset="0"/>
-                <a:ea typeface="Pretendard" pitchFamily="34" charset="-122"/>
-                <a:cs typeface="Pretendard" pitchFamily="34" charset="-120"/>
-              </a:rPr>
-              <a:t>ai-deck-compiler</a:t>
-            </a:r>
-            <a:endParaRPr lang="en-US" sz="1000" dirty="0"/>
-          </a:p>
-        </p:txBody>
-      </p:sp>
-      <p:sp>
-        <p:nvSpPr>
-          <p:cNvPr id="8" name="Text 6"/>
-          <p:cNvSpPr/>
-          <p:nvPr/>
-        </p:nvSpPr>
-        <p:spPr>
-          <a:xfrm>
-            <a:off x="612648" y="6537960"/>
-            <a:ext cx="914400" cy="274320"/>
-          </a:xfrm>
-          <a:prstGeom prst="rect">
-            <a:avLst/>
-          </a:prstGeom>
-          <a:noFill/>
-          <a:ln/>
-        </p:spPr>
-        <p:txBody>
-          <a:bodyPr wrap="square" rtlCol="0" anchor="ctr"/>
-          <a:lstStyle/>
-          <a:p>
-            <a:pPr algn="l" indent="0" marL="0">
-              <a:buNone/>
-            </a:pPr>
-            <a:r>
-              <a:rPr lang="en-US" sz="1000" dirty="0">
-                <a:solidFill>
-                  <a:srgbClr val="7A809A"/>
-                </a:solidFill>
-                <a:latin typeface="Pretendard" pitchFamily="34" charset="0"/>
-                <a:ea typeface="Pretendard" pitchFamily="34" charset="-122"/>
-                <a:cs typeface="Pretendard" pitchFamily="34" charset="-120"/>
-              </a:rPr>
-              <a:t>3 / 6</a:t>
-            </a:r>
-            <a:endParaRPr lang="en-US" sz="1000" dirty="0"/>
+            <a:pPr algn="ctr" indent="0" marL="0">
+              <a:buNone/>
+            </a:pPr>
+            <a:r>
+              <a:rPr lang="en-US" sz="1400" b="1" dirty="0">
+                <a:solidFill>
+                  <a:srgbClr val="FFFFFF"/>
+                </a:solidFill>
+                <a:latin typeface="Pretendard" pitchFamily="34" charset="0"/>
+                <a:ea typeface="Pretendard" pitchFamily="34" charset="-122"/>
+                <a:cs typeface="Pretendard" pitchFamily="34" charset="-120"/>
+              </a:rPr>
+              <a:t>2026년은 파트너십으로 진입하고, 2027년 내재화를 재검토한다.</a:t>
+            </a:r>
+            <a:endParaRPr lang="en-US" sz="1400" dirty="0"/>
           </a:p>
         </p:txBody>
       </p:sp>

</xml_diff>